<commit_message>
Name the model on the setup slide
</commit_message>
<xml_diff>
--- a/slides/2026-09_research_update.pptx
+++ b/slides/2026-09_research_update.pptx
@@ -2626,6 +2626,27 @@
                 <a:ea typeface="Calibri" pitchFamily="34" charset="-122"/>
                 <a:cs typeface="Calibri" pitchFamily="34" charset="-120"/>
               </a:rPr>
+              <a:t>Model: Qwen2.5-Omni-3B, a pretrained multimodal audio-text LLM</a:t>
+            </a:r>
+            <a:endParaRPr lang="en-US" sz="1350" dirty="0"/>
+          </a:p>
+          <a:p>
+            <a:pPr marL="342900" indent="-342900">
+              <a:spcAft>
+                <a:spcPts val="800"/>
+              </a:spcAft>
+              <a:buSzPct val="100000"/>
+              <a:buChar char="•"/>
+            </a:pPr>
+            <a:r>
+              <a:rPr lang="en-US" sz="1350" dirty="0">
+                <a:solidFill>
+                  <a:srgbClr val="26313F"/>
+                </a:solidFill>
+                <a:latin typeface="Calibri" pitchFamily="34" charset="0"/>
+                <a:ea typeface="Calibri" pitchFamily="34" charset="-122"/>
+                <a:cs typeface="Calibri" pitchFamily="34" charset="-120"/>
+              </a:rPr>
               <a:t>6-class speech emotion recognition on IEMOCAP</a:t>
             </a:r>
             <a:endParaRPr lang="en-US" sz="1350" dirty="0"/>

</xml_diff>